<commit_message>
clean the poster draft
</commit_message>
<xml_diff>
--- a/poster/poster_terminology.pptx
+++ b/poster/poster_terminology.pptx
@@ -243,7 +243,7 @@
           <a:p>
             <a:fld id="{051E878B-2824-9044-A243-52A761F375B1}" type="datetimeFigureOut">
               <a:rPr lang="en-KZ" smtClean="0"/>
-              <a:t>07/04/2026</a:t>
+              <a:t>07/05/2026</a:t>
             </a:fld>
             <a:endParaRPr lang="en-KZ"/>
           </a:p>
@@ -413,7 +413,7 @@
           <a:p>
             <a:fld id="{051E878B-2824-9044-A243-52A761F375B1}" type="datetimeFigureOut">
               <a:rPr lang="en-KZ" smtClean="0"/>
-              <a:t>07/04/2026</a:t>
+              <a:t>07/05/2026</a:t>
             </a:fld>
             <a:endParaRPr lang="en-KZ"/>
           </a:p>
@@ -593,7 +593,7 @@
           <a:p>
             <a:fld id="{051E878B-2824-9044-A243-52A761F375B1}" type="datetimeFigureOut">
               <a:rPr lang="en-KZ" smtClean="0"/>
-              <a:t>07/04/2026</a:t>
+              <a:t>07/05/2026</a:t>
             </a:fld>
             <a:endParaRPr lang="en-KZ"/>
           </a:p>
@@ -763,7 +763,7 @@
           <a:p>
             <a:fld id="{051E878B-2824-9044-A243-52A761F375B1}" type="datetimeFigureOut">
               <a:rPr lang="en-KZ" smtClean="0"/>
-              <a:t>07/04/2026</a:t>
+              <a:t>07/05/2026</a:t>
             </a:fld>
             <a:endParaRPr lang="en-KZ"/>
           </a:p>
@@ -1009,7 +1009,7 @@
           <a:p>
             <a:fld id="{051E878B-2824-9044-A243-52A761F375B1}" type="datetimeFigureOut">
               <a:rPr lang="en-KZ" smtClean="0"/>
-              <a:t>07/04/2026</a:t>
+              <a:t>07/05/2026</a:t>
             </a:fld>
             <a:endParaRPr lang="en-KZ"/>
           </a:p>
@@ -1241,7 +1241,7 @@
           <a:p>
             <a:fld id="{051E878B-2824-9044-A243-52A761F375B1}" type="datetimeFigureOut">
               <a:rPr lang="en-KZ" smtClean="0"/>
-              <a:t>07/04/2026</a:t>
+              <a:t>07/05/2026</a:t>
             </a:fld>
             <a:endParaRPr lang="en-KZ"/>
           </a:p>
@@ -1608,7 +1608,7 @@
           <a:p>
             <a:fld id="{051E878B-2824-9044-A243-52A761F375B1}" type="datetimeFigureOut">
               <a:rPr lang="en-KZ" smtClean="0"/>
-              <a:t>07/04/2026</a:t>
+              <a:t>07/05/2026</a:t>
             </a:fld>
             <a:endParaRPr lang="en-KZ"/>
           </a:p>
@@ -1726,7 +1726,7 @@
           <a:p>
             <a:fld id="{051E878B-2824-9044-A243-52A761F375B1}" type="datetimeFigureOut">
               <a:rPr lang="en-KZ" smtClean="0"/>
-              <a:t>07/04/2026</a:t>
+              <a:t>07/05/2026</a:t>
             </a:fld>
             <a:endParaRPr lang="en-KZ"/>
           </a:p>
@@ -1821,7 +1821,7 @@
           <a:p>
             <a:fld id="{051E878B-2824-9044-A243-52A761F375B1}" type="datetimeFigureOut">
               <a:rPr lang="en-KZ" smtClean="0"/>
-              <a:t>07/04/2026</a:t>
+              <a:t>07/05/2026</a:t>
             </a:fld>
             <a:endParaRPr lang="en-KZ"/>
           </a:p>
@@ -2098,7 +2098,7 @@
           <a:p>
             <a:fld id="{051E878B-2824-9044-A243-52A761F375B1}" type="datetimeFigureOut">
               <a:rPr lang="en-KZ" smtClean="0"/>
-              <a:t>07/04/2026</a:t>
+              <a:t>07/05/2026</a:t>
             </a:fld>
             <a:endParaRPr lang="en-KZ"/>
           </a:p>
@@ -2355,7 +2355,7 @@
           <a:p>
             <a:fld id="{051E878B-2824-9044-A243-52A761F375B1}" type="datetimeFigureOut">
               <a:rPr lang="en-KZ" smtClean="0"/>
-              <a:t>07/04/2026</a:t>
+              <a:t>07/05/2026</a:t>
             </a:fld>
             <a:endParaRPr lang="en-KZ"/>
           </a:p>
@@ -2568,7 +2568,7 @@
           <a:p>
             <a:fld id="{051E878B-2824-9044-A243-52A761F375B1}" type="datetimeFigureOut">
               <a:rPr lang="en-KZ" smtClean="0"/>
-              <a:t>07/04/2026</a:t>
+              <a:t>07/05/2026</a:t>
             </a:fld>
             <a:endParaRPr lang="en-KZ"/>
           </a:p>
@@ -3523,1829 +3523,6 @@
           </a:p>
         </p:txBody>
       </p:sp>
-      <p:pic>
-        <p:nvPicPr>
-          <p:cNvPr id="3" name="Picture 2">
-            <a:extLst>
-              <a:ext uri="{FF2B5EF4-FFF2-40B4-BE49-F238E27FC236}">
-                <a16:creationId xmlns:a16="http://schemas.microsoft.com/office/drawing/2014/main" id="{519C7F8C-0A33-AE45-A08B-781CF1D7F9EE}"/>
-              </a:ext>
-            </a:extLst>
-          </p:cNvPr>
-          <p:cNvPicPr>
-            <a:picLocks noChangeAspect="1"/>
-          </p:cNvPicPr>
-          <p:nvPr/>
-        </p:nvPicPr>
-        <p:blipFill>
-          <a:blip r:embed="rId2"/>
-          <a:stretch>
-            <a:fillRect/>
-          </a:stretch>
-        </p:blipFill>
-        <p:spPr>
-          <a:xfrm>
-            <a:off x="17624453" y="8324091"/>
-            <a:ext cx="12757712" cy="6729693"/>
-          </a:xfrm>
-          <a:prstGeom prst="rect">
-            <a:avLst/>
-          </a:prstGeom>
-        </p:spPr>
-      </p:pic>
-      <p:pic>
-        <p:nvPicPr>
-          <p:cNvPr id="14" name="Picture 13">
-            <a:extLst>
-              <a:ext uri="{FF2B5EF4-FFF2-40B4-BE49-F238E27FC236}">
-                <a16:creationId xmlns:a16="http://schemas.microsoft.com/office/drawing/2014/main" id="{0B5B9497-ABC5-6F96-455E-327B1E1B804D}"/>
-              </a:ext>
-            </a:extLst>
-          </p:cNvPr>
-          <p:cNvPicPr>
-            <a:picLocks noChangeAspect="1"/>
-          </p:cNvPicPr>
-          <p:nvPr/>
-        </p:nvPicPr>
-        <p:blipFill>
-          <a:blip r:embed="rId3"/>
-          <a:stretch>
-            <a:fillRect/>
-          </a:stretch>
-        </p:blipFill>
-        <p:spPr>
-          <a:xfrm>
-            <a:off x="6644617" y="18762618"/>
-            <a:ext cx="11109983" cy="4373889"/>
-          </a:xfrm>
-          <a:prstGeom prst="rect">
-            <a:avLst/>
-          </a:prstGeom>
-        </p:spPr>
-      </p:pic>
-      <p:pic>
-        <p:nvPicPr>
-          <p:cNvPr id="20" name="Picture 19">
-            <a:extLst>
-              <a:ext uri="{FF2B5EF4-FFF2-40B4-BE49-F238E27FC236}">
-                <a16:creationId xmlns:a16="http://schemas.microsoft.com/office/drawing/2014/main" id="{73E74209-E430-0266-1781-51068746FCA6}"/>
-              </a:ext>
-            </a:extLst>
-          </p:cNvPr>
-          <p:cNvPicPr>
-            <a:picLocks noChangeAspect="1"/>
-          </p:cNvPicPr>
-          <p:nvPr/>
-        </p:nvPicPr>
-        <p:blipFill>
-          <a:blip r:embed="rId4"/>
-          <a:stretch>
-            <a:fillRect/>
-          </a:stretch>
-        </p:blipFill>
-        <p:spPr>
-          <a:xfrm>
-            <a:off x="20636056" y="18490933"/>
-            <a:ext cx="8942850" cy="4376937"/>
-          </a:xfrm>
-          <a:prstGeom prst="rect">
-            <a:avLst/>
-          </a:prstGeom>
-        </p:spPr>
-      </p:pic>
-      <p:pic>
-        <p:nvPicPr>
-          <p:cNvPr id="25" name="Picture 24">
-            <a:extLst>
-              <a:ext uri="{FF2B5EF4-FFF2-40B4-BE49-F238E27FC236}">
-                <a16:creationId xmlns:a16="http://schemas.microsoft.com/office/drawing/2014/main" id="{E963AEC4-805E-E796-EF88-EB9AD9E1EE7C}"/>
-              </a:ext>
-            </a:extLst>
-          </p:cNvPr>
-          <p:cNvPicPr>
-            <a:picLocks noChangeAspect="1"/>
-          </p:cNvPicPr>
-          <p:nvPr/>
-        </p:nvPicPr>
-        <p:blipFill>
-          <a:blip r:embed="rId5"/>
-          <a:stretch>
-            <a:fillRect/>
-          </a:stretch>
-        </p:blipFill>
-        <p:spPr>
-          <a:xfrm>
-            <a:off x="2194493" y="29771514"/>
-            <a:ext cx="27384413" cy="2310559"/>
-          </a:xfrm>
-          <a:prstGeom prst="rect">
-            <a:avLst/>
-          </a:prstGeom>
-        </p:spPr>
-      </p:pic>
-      <p:graphicFrame>
-        <p:nvGraphicFramePr>
-          <p:cNvPr id="26" name="Table 25">
-            <a:extLst>
-              <a:ext uri="{FF2B5EF4-FFF2-40B4-BE49-F238E27FC236}">
-                <a16:creationId xmlns:a16="http://schemas.microsoft.com/office/drawing/2014/main" id="{B76CE51A-29F1-725B-7C2C-80EF7878D38D}"/>
-              </a:ext>
-            </a:extLst>
-          </p:cNvPr>
-          <p:cNvGraphicFramePr>
-            <a:graphicFrameLocks noGrp="1"/>
-          </p:cNvGraphicFramePr>
-          <p:nvPr/>
-        </p:nvGraphicFramePr>
-        <p:xfrm>
-          <a:off x="10621963" y="20853400"/>
-          <a:ext cx="9029700" cy="1097280"/>
-        </p:xfrm>
-        <a:graphic>
-          <a:graphicData uri="http://schemas.openxmlformats.org/drawingml/2006/table">
-            <a:tbl>
-              <a:tblPr>
-                <a:tableStyleId>{5C22544A-7EE6-4342-B048-85BDC9FD1C3A}</a:tableStyleId>
-              </a:tblPr>
-              <a:tblGrid>
-                <a:gridCol w="850900">
-                  <a:extLst>
-                    <a:ext uri="{9D8B030D-6E8A-4147-A177-3AD203B41FA5}">
-                      <a16:colId xmlns:a16="http://schemas.microsoft.com/office/drawing/2014/main" val="168947069"/>
-                    </a:ext>
-                  </a:extLst>
-                </a:gridCol>
-                <a:gridCol w="431800">
-                  <a:extLst>
-                    <a:ext uri="{9D8B030D-6E8A-4147-A177-3AD203B41FA5}">
-                      <a16:colId xmlns:a16="http://schemas.microsoft.com/office/drawing/2014/main" val="2184802070"/>
-                    </a:ext>
-                  </a:extLst>
-                </a:gridCol>
-                <a:gridCol w="431800">
-                  <a:extLst>
-                    <a:ext uri="{9D8B030D-6E8A-4147-A177-3AD203B41FA5}">
-                      <a16:colId xmlns:a16="http://schemas.microsoft.com/office/drawing/2014/main" val="3020362902"/>
-                    </a:ext>
-                  </a:extLst>
-                </a:gridCol>
-                <a:gridCol w="863600">
-                  <a:extLst>
-                    <a:ext uri="{9D8B030D-6E8A-4147-A177-3AD203B41FA5}">
-                      <a16:colId xmlns:a16="http://schemas.microsoft.com/office/drawing/2014/main" val="1690818549"/>
-                    </a:ext>
-                  </a:extLst>
-                </a:gridCol>
-                <a:gridCol w="1054100">
-                  <a:extLst>
-                    <a:ext uri="{9D8B030D-6E8A-4147-A177-3AD203B41FA5}">
-                      <a16:colId xmlns:a16="http://schemas.microsoft.com/office/drawing/2014/main" val="3220897374"/>
-                    </a:ext>
-                  </a:extLst>
-                </a:gridCol>
-                <a:gridCol w="1308100">
-                  <a:extLst>
-                    <a:ext uri="{9D8B030D-6E8A-4147-A177-3AD203B41FA5}">
-                      <a16:colId xmlns:a16="http://schemas.microsoft.com/office/drawing/2014/main" val="1406790128"/>
-                    </a:ext>
-                  </a:extLst>
-                </a:gridCol>
-                <a:gridCol w="431800">
-                  <a:extLst>
-                    <a:ext uri="{9D8B030D-6E8A-4147-A177-3AD203B41FA5}">
-                      <a16:colId xmlns:a16="http://schemas.microsoft.com/office/drawing/2014/main" val="2842590171"/>
-                    </a:ext>
-                  </a:extLst>
-                </a:gridCol>
-                <a:gridCol w="431800">
-                  <a:extLst>
-                    <a:ext uri="{9D8B030D-6E8A-4147-A177-3AD203B41FA5}">
-                      <a16:colId xmlns:a16="http://schemas.microsoft.com/office/drawing/2014/main" val="520473253"/>
-                    </a:ext>
-                  </a:extLst>
-                </a:gridCol>
-                <a:gridCol w="863600">
-                  <a:extLst>
-                    <a:ext uri="{9D8B030D-6E8A-4147-A177-3AD203B41FA5}">
-                      <a16:colId xmlns:a16="http://schemas.microsoft.com/office/drawing/2014/main" val="3365999837"/>
-                    </a:ext>
-                  </a:extLst>
-                </a:gridCol>
-                <a:gridCol w="1054100">
-                  <a:extLst>
-                    <a:ext uri="{9D8B030D-6E8A-4147-A177-3AD203B41FA5}">
-                      <a16:colId xmlns:a16="http://schemas.microsoft.com/office/drawing/2014/main" val="3629754852"/>
-                    </a:ext>
-                  </a:extLst>
-                </a:gridCol>
-                <a:gridCol w="1308100">
-                  <a:extLst>
-                    <a:ext uri="{9D8B030D-6E8A-4147-A177-3AD203B41FA5}">
-                      <a16:colId xmlns:a16="http://schemas.microsoft.com/office/drawing/2014/main" val="626875518"/>
-                    </a:ext>
-                  </a:extLst>
-                </a:gridCol>
-              </a:tblGrid>
-              <a:tr h="182880">
-                <a:tc>
-                  <a:txBody>
-                    <a:bodyPr/>
-                    <a:lstStyle/>
-                    <a:p>
-                      <a:pPr algn="l" fontAlgn="b">
-                        <a:buNone/>
-                      </a:pPr>
-                      <a:endParaRPr lang="en-US" sz="1100" b="1" i="0" u="none" strike="noStrike">
-                        <a:solidFill>
-                          <a:srgbClr val="000000"/>
-                        </a:solidFill>
-                        <a:effectLst/>
-                        <a:latin typeface="Calibri" panose="020F0502020204030204" pitchFamily="34" charset="0"/>
-                      </a:endParaRPr>
-                    </a:p>
-                  </a:txBody>
-                  <a:tcPr marL="7620" marR="7620" marT="7620" marB="0" anchor="b"/>
-                </a:tc>
-                <a:tc gridSpan="5">
-                  <a:txBody>
-                    <a:bodyPr/>
-                    <a:lstStyle/>
-                    <a:p>
-                      <a:pPr algn="ctr" fontAlgn="b">
-                        <a:buNone/>
-                      </a:pPr>
-                      <a:r>
-                        <a:rPr lang="en-US" sz="1100" u="none" strike="noStrike">
-                          <a:effectLst/>
-                        </a:rPr>
-                        <a:t>qwen_lora_7b_no_few_shots_3_epochs</a:t>
-                      </a:r>
-                      <a:endParaRPr lang="en-US" sz="1100" b="0" i="0" u="none" strike="noStrike">
-                        <a:solidFill>
-                          <a:srgbClr val="000000"/>
-                        </a:solidFill>
-                        <a:effectLst/>
-                        <a:latin typeface="Calibri" panose="020F0502020204030204" pitchFamily="34" charset="0"/>
-                      </a:endParaRPr>
-                    </a:p>
-                  </a:txBody>
-                  <a:tcPr marL="7620" marR="7620" marT="7620" marB="0" anchor="b"/>
-                </a:tc>
-                <a:tc hMerge="1">
-                  <a:txBody>
-                    <a:bodyPr/>
-                    <a:lstStyle/>
-                    <a:p>
-                      <a:endParaRPr lang="en-US"/>
-                    </a:p>
-                  </a:txBody>
-                  <a:tcPr/>
-                </a:tc>
-                <a:tc hMerge="1">
-                  <a:txBody>
-                    <a:bodyPr/>
-                    <a:lstStyle/>
-                    <a:p>
-                      <a:endParaRPr lang="en-US"/>
-                    </a:p>
-                  </a:txBody>
-                  <a:tcPr/>
-                </a:tc>
-                <a:tc hMerge="1">
-                  <a:txBody>
-                    <a:bodyPr/>
-                    <a:lstStyle/>
-                    <a:p>
-                      <a:endParaRPr lang="en-US"/>
-                    </a:p>
-                  </a:txBody>
-                  <a:tcPr/>
-                </a:tc>
-                <a:tc hMerge="1">
-                  <a:txBody>
-                    <a:bodyPr/>
-                    <a:lstStyle/>
-                    <a:p>
-                      <a:endParaRPr lang="en-US"/>
-                    </a:p>
-                  </a:txBody>
-                  <a:tcPr/>
-                </a:tc>
-                <a:tc gridSpan="5">
-                  <a:txBody>
-                    <a:bodyPr/>
-                    <a:lstStyle/>
-                    <a:p>
-                      <a:pPr algn="ctr" fontAlgn="b">
-                        <a:buNone/>
-                      </a:pPr>
-                      <a:r>
-                        <a:rPr lang="en-US" sz="1100" u="none" strike="noStrike">
-                          <a:effectLst/>
-                        </a:rPr>
-                        <a:t>gpt_4o_mini</a:t>
-                      </a:r>
-                      <a:endParaRPr lang="en-US" sz="1100" b="0" i="0" u="none" strike="noStrike">
-                        <a:solidFill>
-                          <a:srgbClr val="000000"/>
-                        </a:solidFill>
-                        <a:effectLst/>
-                        <a:latin typeface="Calibri" panose="020F0502020204030204" pitchFamily="34" charset="0"/>
-                      </a:endParaRPr>
-                    </a:p>
-                  </a:txBody>
-                  <a:tcPr marL="7620" marR="7620" marT="7620" marB="0" anchor="b"/>
-                </a:tc>
-                <a:tc hMerge="1">
-                  <a:txBody>
-                    <a:bodyPr/>
-                    <a:lstStyle/>
-                    <a:p>
-                      <a:endParaRPr lang="en-US"/>
-                    </a:p>
-                  </a:txBody>
-                  <a:tcPr/>
-                </a:tc>
-                <a:tc hMerge="1">
-                  <a:txBody>
-                    <a:bodyPr/>
-                    <a:lstStyle/>
-                    <a:p>
-                      <a:endParaRPr lang="en-US"/>
-                    </a:p>
-                  </a:txBody>
-                  <a:tcPr/>
-                </a:tc>
-                <a:tc hMerge="1">
-                  <a:txBody>
-                    <a:bodyPr/>
-                    <a:lstStyle/>
-                    <a:p>
-                      <a:endParaRPr lang="en-US"/>
-                    </a:p>
-                  </a:txBody>
-                  <a:tcPr/>
-                </a:tc>
-                <a:tc hMerge="1">
-                  <a:txBody>
-                    <a:bodyPr/>
-                    <a:lstStyle/>
-                    <a:p>
-                      <a:endParaRPr lang="en-US"/>
-                    </a:p>
-                  </a:txBody>
-                  <a:tcPr/>
-                </a:tc>
-                <a:extLst>
-                  <a:ext uri="{0D108BD9-81ED-4DB2-BD59-A6C34878D82A}">
-                    <a16:rowId xmlns:a16="http://schemas.microsoft.com/office/drawing/2014/main" val="2390109045"/>
-                  </a:ext>
-                </a:extLst>
-              </a:tr>
-              <a:tr h="182880">
-                <a:tc>
-                  <a:txBody>
-                    <a:bodyPr/>
-                    <a:lstStyle/>
-                    <a:p>
-                      <a:pPr algn="l" fontAlgn="b">
-                        <a:buNone/>
-                      </a:pPr>
-                      <a:r>
-                        <a:rPr lang="en-US" sz="1100" u="none" strike="noStrike">
-                          <a:effectLst/>
-                        </a:rPr>
-                        <a:t>lang_pair</a:t>
-                      </a:r>
-                      <a:endParaRPr lang="en-US" sz="1100" b="0" i="0" u="none" strike="noStrike">
-                        <a:solidFill>
-                          <a:srgbClr val="000000"/>
-                        </a:solidFill>
-                        <a:effectLst/>
-                        <a:latin typeface="Calibri" panose="020F0502020204030204" pitchFamily="34" charset="0"/>
-                      </a:endParaRPr>
-                    </a:p>
-                  </a:txBody>
-                  <a:tcPr marL="7620" marR="7620" marT="7620" marB="0" anchor="b"/>
-                </a:tc>
-                <a:tc>
-                  <a:txBody>
-                    <a:bodyPr/>
-                    <a:lstStyle/>
-                    <a:p>
-                      <a:pPr algn="l" fontAlgn="b">
-                        <a:buNone/>
-                      </a:pPr>
-                      <a:r>
-                        <a:rPr lang="en-US" sz="1100" u="none" strike="noStrike">
-                          <a:effectLst/>
-                        </a:rPr>
-                        <a:t>BLEU</a:t>
-                      </a:r>
-                      <a:endParaRPr lang="en-US" sz="1100" b="0" i="0" u="none" strike="noStrike">
-                        <a:solidFill>
-                          <a:srgbClr val="000000"/>
-                        </a:solidFill>
-                        <a:effectLst/>
-                        <a:latin typeface="Calibri" panose="020F0502020204030204" pitchFamily="34" charset="0"/>
-                      </a:endParaRPr>
-                    </a:p>
-                  </a:txBody>
-                  <a:tcPr marL="7620" marR="7620" marT="7620" marB="0" anchor="b"/>
-                </a:tc>
-                <a:tc>
-                  <a:txBody>
-                    <a:bodyPr/>
-                    <a:lstStyle/>
-                    <a:p>
-                      <a:pPr algn="l" fontAlgn="b">
-                        <a:buNone/>
-                      </a:pPr>
-                      <a:r>
-                        <a:rPr lang="en-US" sz="1100" u="none" strike="noStrike">
-                          <a:effectLst/>
-                        </a:rPr>
-                        <a:t>chrF</a:t>
-                      </a:r>
-                      <a:endParaRPr lang="en-US" sz="1100" b="0" i="0" u="none" strike="noStrike">
-                        <a:solidFill>
-                          <a:srgbClr val="000000"/>
-                        </a:solidFill>
-                        <a:effectLst/>
-                        <a:latin typeface="Calibri" panose="020F0502020204030204" pitchFamily="34" charset="0"/>
-                      </a:endParaRPr>
-                    </a:p>
-                  </a:txBody>
-                  <a:tcPr marL="7620" marR="7620" marT="7620" marB="0" anchor="b"/>
-                </a:tc>
-                <a:tc>
-                  <a:txBody>
-                    <a:bodyPr/>
-                    <a:lstStyle/>
-                    <a:p>
-                      <a:pPr algn="l" fontAlgn="b">
-                        <a:buNone/>
-                      </a:pPr>
-                      <a:r>
-                        <a:rPr lang="en-US" sz="1100" u="none" strike="noStrike">
-                          <a:effectLst/>
-                        </a:rPr>
-                        <a:t>Term Acc (%)</a:t>
-                      </a:r>
-                      <a:endParaRPr lang="en-US" sz="1100" b="0" i="0" u="none" strike="noStrike">
-                        <a:solidFill>
-                          <a:srgbClr val="000000"/>
-                        </a:solidFill>
-                        <a:effectLst/>
-                        <a:latin typeface="Calibri" panose="020F0502020204030204" pitchFamily="34" charset="0"/>
-                      </a:endParaRPr>
-                    </a:p>
-                  </a:txBody>
-                  <a:tcPr marL="7620" marR="7620" marT="7620" marB="0" anchor="b"/>
-                </a:tc>
-                <a:tc>
-                  <a:txBody>
-                    <a:bodyPr/>
-                    <a:lstStyle/>
-                    <a:p>
-                      <a:pPr algn="l" fontAlgn="b">
-                        <a:buNone/>
-                      </a:pPr>
-                      <a:r>
-                        <a:rPr lang="en-US" sz="1100" u="none" strike="noStrike">
-                          <a:effectLst/>
-                        </a:rPr>
-                        <a:t>Cons Macro Avg</a:t>
-                      </a:r>
-                      <a:endParaRPr lang="en-US" sz="1100" b="0" i="0" u="none" strike="noStrike">
-                        <a:solidFill>
-                          <a:srgbClr val="000000"/>
-                        </a:solidFill>
-                        <a:effectLst/>
-                        <a:latin typeface="Calibri" panose="020F0502020204030204" pitchFamily="34" charset="0"/>
-                      </a:endParaRPr>
-                    </a:p>
-                  </a:txBody>
-                  <a:tcPr marL="7620" marR="7620" marT="7620" marB="0" anchor="b"/>
-                </a:tc>
-                <a:tc>
-                  <a:txBody>
-                    <a:bodyPr/>
-                    <a:lstStyle/>
-                    <a:p>
-                      <a:pPr algn="l" fontAlgn="b">
-                        <a:buNone/>
-                      </a:pPr>
-                      <a:r>
-                        <a:rPr lang="en-US" sz="1100" u="none" strike="noStrike">
-                          <a:effectLst/>
-                        </a:rPr>
-                        <a:t>Cons Weighted Avg</a:t>
-                      </a:r>
-                      <a:endParaRPr lang="en-US" sz="1100" b="0" i="0" u="none" strike="noStrike">
-                        <a:solidFill>
-                          <a:srgbClr val="000000"/>
-                        </a:solidFill>
-                        <a:effectLst/>
-                        <a:latin typeface="Calibri" panose="020F0502020204030204" pitchFamily="34" charset="0"/>
-                      </a:endParaRPr>
-                    </a:p>
-                  </a:txBody>
-                  <a:tcPr marL="7620" marR="7620" marT="7620" marB="0" anchor="b"/>
-                </a:tc>
-                <a:tc>
-                  <a:txBody>
-                    <a:bodyPr/>
-                    <a:lstStyle/>
-                    <a:p>
-                      <a:pPr algn="l" fontAlgn="b">
-                        <a:buNone/>
-                      </a:pPr>
-                      <a:r>
-                        <a:rPr lang="en-US" sz="1100" u="none" strike="noStrike">
-                          <a:effectLst/>
-                        </a:rPr>
-                        <a:t>BLEU</a:t>
-                      </a:r>
-                      <a:endParaRPr lang="en-US" sz="1100" b="0" i="0" u="none" strike="noStrike">
-                        <a:solidFill>
-                          <a:srgbClr val="000000"/>
-                        </a:solidFill>
-                        <a:effectLst/>
-                        <a:latin typeface="Calibri" panose="020F0502020204030204" pitchFamily="34" charset="0"/>
-                      </a:endParaRPr>
-                    </a:p>
-                  </a:txBody>
-                  <a:tcPr marL="7620" marR="7620" marT="7620" marB="0" anchor="b"/>
-                </a:tc>
-                <a:tc>
-                  <a:txBody>
-                    <a:bodyPr/>
-                    <a:lstStyle/>
-                    <a:p>
-                      <a:pPr algn="l" fontAlgn="b">
-                        <a:buNone/>
-                      </a:pPr>
-                      <a:r>
-                        <a:rPr lang="en-US" sz="1100" u="none" strike="noStrike">
-                          <a:effectLst/>
-                        </a:rPr>
-                        <a:t>chrF</a:t>
-                      </a:r>
-                      <a:endParaRPr lang="en-US" sz="1100" b="0" i="0" u="none" strike="noStrike">
-                        <a:solidFill>
-                          <a:srgbClr val="000000"/>
-                        </a:solidFill>
-                        <a:effectLst/>
-                        <a:latin typeface="Calibri" panose="020F0502020204030204" pitchFamily="34" charset="0"/>
-                      </a:endParaRPr>
-                    </a:p>
-                  </a:txBody>
-                  <a:tcPr marL="7620" marR="7620" marT="7620" marB="0" anchor="b"/>
-                </a:tc>
-                <a:tc>
-                  <a:txBody>
-                    <a:bodyPr/>
-                    <a:lstStyle/>
-                    <a:p>
-                      <a:pPr algn="l" fontAlgn="b">
-                        <a:buNone/>
-                      </a:pPr>
-                      <a:r>
-                        <a:rPr lang="en-US" sz="1100" u="none" strike="noStrike">
-                          <a:effectLst/>
-                        </a:rPr>
-                        <a:t>Term Acc (%)</a:t>
-                      </a:r>
-                      <a:endParaRPr lang="en-US" sz="1100" b="0" i="0" u="none" strike="noStrike">
-                        <a:solidFill>
-                          <a:srgbClr val="000000"/>
-                        </a:solidFill>
-                        <a:effectLst/>
-                        <a:latin typeface="Calibri" panose="020F0502020204030204" pitchFamily="34" charset="0"/>
-                      </a:endParaRPr>
-                    </a:p>
-                  </a:txBody>
-                  <a:tcPr marL="7620" marR="7620" marT="7620" marB="0" anchor="b"/>
-                </a:tc>
-                <a:tc>
-                  <a:txBody>
-                    <a:bodyPr/>
-                    <a:lstStyle/>
-                    <a:p>
-                      <a:pPr algn="l" fontAlgn="b">
-                        <a:buNone/>
-                      </a:pPr>
-                      <a:r>
-                        <a:rPr lang="en-US" sz="1100" u="none" strike="noStrike">
-                          <a:effectLst/>
-                        </a:rPr>
-                        <a:t>Cons Macro Avg</a:t>
-                      </a:r>
-                      <a:endParaRPr lang="en-US" sz="1100" b="0" i="0" u="none" strike="noStrike">
-                        <a:solidFill>
-                          <a:srgbClr val="000000"/>
-                        </a:solidFill>
-                        <a:effectLst/>
-                        <a:latin typeface="Calibri" panose="020F0502020204030204" pitchFamily="34" charset="0"/>
-                      </a:endParaRPr>
-                    </a:p>
-                  </a:txBody>
-                  <a:tcPr marL="7620" marR="7620" marT="7620" marB="0" anchor="b"/>
-                </a:tc>
-                <a:tc>
-                  <a:txBody>
-                    <a:bodyPr/>
-                    <a:lstStyle/>
-                    <a:p>
-                      <a:pPr algn="l" fontAlgn="b">
-                        <a:buNone/>
-                      </a:pPr>
-                      <a:r>
-                        <a:rPr lang="en-US" sz="1100" u="none" strike="noStrike">
-                          <a:effectLst/>
-                        </a:rPr>
-                        <a:t>Cons Weighted Avg</a:t>
-                      </a:r>
-                      <a:endParaRPr lang="en-US" sz="1100" b="0" i="0" u="none" strike="noStrike">
-                        <a:solidFill>
-                          <a:srgbClr val="000000"/>
-                        </a:solidFill>
-                        <a:effectLst/>
-                        <a:latin typeface="Calibri" panose="020F0502020204030204" pitchFamily="34" charset="0"/>
-                      </a:endParaRPr>
-                    </a:p>
-                  </a:txBody>
-                  <a:tcPr marL="7620" marR="7620" marT="7620" marB="0" anchor="b"/>
-                </a:tc>
-                <a:extLst>
-                  <a:ext uri="{0D108BD9-81ED-4DB2-BD59-A6C34878D82A}">
-                    <a16:rowId xmlns:a16="http://schemas.microsoft.com/office/drawing/2014/main" val="3069859168"/>
-                  </a:ext>
-                </a:extLst>
-              </a:tr>
-              <a:tr h="182880">
-                <a:tc>
-                  <a:txBody>
-                    <a:bodyPr/>
-                    <a:lstStyle/>
-                    <a:p>
-                      <a:pPr algn="l" fontAlgn="b">
-                        <a:buNone/>
-                      </a:pPr>
-                      <a:r>
-                        <a:rPr lang="en-US" sz="1100" u="none" strike="noStrike">
-                          <a:effectLst/>
-                        </a:rPr>
-                        <a:t>en→de</a:t>
-                      </a:r>
-                      <a:endParaRPr lang="en-US" sz="1100" b="0" i="0" u="none" strike="noStrike">
-                        <a:solidFill>
-                          <a:srgbClr val="000000"/>
-                        </a:solidFill>
-                        <a:effectLst/>
-                        <a:latin typeface="Calibri" panose="020F0502020204030204" pitchFamily="34" charset="0"/>
-                      </a:endParaRPr>
-                    </a:p>
-                  </a:txBody>
-                  <a:tcPr marL="7620" marR="7620" marT="7620" marB="0" anchor="b"/>
-                </a:tc>
-                <a:tc>
-                  <a:txBody>
-                    <a:bodyPr/>
-                    <a:lstStyle/>
-                    <a:p>
-                      <a:pPr algn="r" fontAlgn="b">
-                        <a:buNone/>
-                      </a:pPr>
-                      <a:r>
-                        <a:rPr lang="en-US" sz="1100" u="none" strike="noStrike">
-                          <a:effectLst/>
-                        </a:rPr>
-                        <a:t>46.29</a:t>
-                      </a:r>
-                      <a:endParaRPr lang="en-US" sz="1100" b="0" i="0" u="none" strike="noStrike">
-                        <a:solidFill>
-                          <a:srgbClr val="000000"/>
-                        </a:solidFill>
-                        <a:effectLst/>
-                        <a:latin typeface="Calibri" panose="020F0502020204030204" pitchFamily="34" charset="0"/>
-                      </a:endParaRPr>
-                    </a:p>
-                  </a:txBody>
-                  <a:tcPr marL="7620" marR="7620" marT="7620" marB="0" anchor="b"/>
-                </a:tc>
-                <a:tc>
-                  <a:txBody>
-                    <a:bodyPr/>
-                    <a:lstStyle/>
-                    <a:p>
-                      <a:pPr algn="r" fontAlgn="b">
-                        <a:buNone/>
-                      </a:pPr>
-                      <a:r>
-                        <a:rPr lang="en-US" sz="1100" u="none" strike="noStrike">
-                          <a:effectLst/>
-                        </a:rPr>
-                        <a:t>72.08</a:t>
-                      </a:r>
-                      <a:endParaRPr lang="en-US" sz="1100" b="0" i="0" u="none" strike="noStrike">
-                        <a:solidFill>
-                          <a:srgbClr val="000000"/>
-                        </a:solidFill>
-                        <a:effectLst/>
-                        <a:latin typeface="Calibri" panose="020F0502020204030204" pitchFamily="34" charset="0"/>
-                      </a:endParaRPr>
-                    </a:p>
-                  </a:txBody>
-                  <a:tcPr marL="7620" marR="7620" marT="7620" marB="0" anchor="b"/>
-                </a:tc>
-                <a:tc>
-                  <a:txBody>
-                    <a:bodyPr/>
-                    <a:lstStyle/>
-                    <a:p>
-                      <a:pPr algn="r" fontAlgn="b">
-                        <a:buNone/>
-                      </a:pPr>
-                      <a:r>
-                        <a:rPr lang="en-US" sz="1100" u="none" strike="noStrike">
-                          <a:effectLst/>
-                        </a:rPr>
-                        <a:t>55.58</a:t>
-                      </a:r>
-                      <a:endParaRPr lang="en-US" sz="1100" b="0" i="0" u="none" strike="noStrike">
-                        <a:solidFill>
-                          <a:srgbClr val="000000"/>
-                        </a:solidFill>
-                        <a:effectLst/>
-                        <a:latin typeface="Calibri" panose="020F0502020204030204" pitchFamily="34" charset="0"/>
-                      </a:endParaRPr>
-                    </a:p>
-                  </a:txBody>
-                  <a:tcPr marL="7620" marR="7620" marT="7620" marB="0" anchor="b"/>
-                </a:tc>
-                <a:tc>
-                  <a:txBody>
-                    <a:bodyPr/>
-                    <a:lstStyle/>
-                    <a:p>
-                      <a:pPr algn="r" fontAlgn="b">
-                        <a:buNone/>
-                      </a:pPr>
-                      <a:r>
-                        <a:rPr lang="en-US" sz="1100" u="none" strike="noStrike">
-                          <a:effectLst/>
-                        </a:rPr>
-                        <a:t>0.8977</a:t>
-                      </a:r>
-                      <a:endParaRPr lang="en-US" sz="1100" b="0" i="0" u="none" strike="noStrike">
-                        <a:solidFill>
-                          <a:srgbClr val="000000"/>
-                        </a:solidFill>
-                        <a:effectLst/>
-                        <a:latin typeface="Calibri" panose="020F0502020204030204" pitchFamily="34" charset="0"/>
-                      </a:endParaRPr>
-                    </a:p>
-                  </a:txBody>
-                  <a:tcPr marL="7620" marR="7620" marT="7620" marB="0" anchor="b"/>
-                </a:tc>
-                <a:tc>
-                  <a:txBody>
-                    <a:bodyPr/>
-                    <a:lstStyle/>
-                    <a:p>
-                      <a:pPr algn="r" fontAlgn="b">
-                        <a:buNone/>
-                      </a:pPr>
-                      <a:r>
-                        <a:rPr lang="en-US" sz="1100" u="none" strike="noStrike">
-                          <a:effectLst/>
-                        </a:rPr>
-                        <a:t>0.7993</a:t>
-                      </a:r>
-                      <a:endParaRPr lang="en-US" sz="1100" b="0" i="0" u="none" strike="noStrike">
-                        <a:solidFill>
-                          <a:srgbClr val="000000"/>
-                        </a:solidFill>
-                        <a:effectLst/>
-                        <a:latin typeface="Calibri" panose="020F0502020204030204" pitchFamily="34" charset="0"/>
-                      </a:endParaRPr>
-                    </a:p>
-                  </a:txBody>
-                  <a:tcPr marL="7620" marR="7620" marT="7620" marB="0" anchor="b"/>
-                </a:tc>
-                <a:tc>
-                  <a:txBody>
-                    <a:bodyPr/>
-                    <a:lstStyle/>
-                    <a:p>
-                      <a:pPr algn="r" fontAlgn="b">
-                        <a:buNone/>
-                      </a:pPr>
-                      <a:r>
-                        <a:rPr lang="en-US" sz="1100" u="none" strike="noStrike">
-                          <a:effectLst/>
-                        </a:rPr>
-                        <a:t>47.83</a:t>
-                      </a:r>
-                      <a:endParaRPr lang="en-US" sz="1100" b="0" i="0" u="none" strike="noStrike">
-                        <a:solidFill>
-                          <a:srgbClr val="000000"/>
-                        </a:solidFill>
-                        <a:effectLst/>
-                        <a:latin typeface="Calibri" panose="020F0502020204030204" pitchFamily="34" charset="0"/>
-                      </a:endParaRPr>
-                    </a:p>
-                  </a:txBody>
-                  <a:tcPr marL="7620" marR="7620" marT="7620" marB="0" anchor="b"/>
-                </a:tc>
-                <a:tc>
-                  <a:txBody>
-                    <a:bodyPr/>
-                    <a:lstStyle/>
-                    <a:p>
-                      <a:pPr algn="r" fontAlgn="b">
-                        <a:buNone/>
-                      </a:pPr>
-                      <a:r>
-                        <a:rPr lang="en-US" sz="1100" u="none" strike="noStrike">
-                          <a:effectLst/>
-                        </a:rPr>
-                        <a:t>73.75</a:t>
-                      </a:r>
-                      <a:endParaRPr lang="en-US" sz="1100" b="0" i="0" u="none" strike="noStrike">
-                        <a:solidFill>
-                          <a:srgbClr val="000000"/>
-                        </a:solidFill>
-                        <a:effectLst/>
-                        <a:latin typeface="Calibri" panose="020F0502020204030204" pitchFamily="34" charset="0"/>
-                      </a:endParaRPr>
-                    </a:p>
-                  </a:txBody>
-                  <a:tcPr marL="7620" marR="7620" marT="7620" marB="0" anchor="b"/>
-                </a:tc>
-                <a:tc>
-                  <a:txBody>
-                    <a:bodyPr/>
-                    <a:lstStyle/>
-                    <a:p>
-                      <a:pPr algn="r" fontAlgn="b">
-                        <a:buNone/>
-                      </a:pPr>
-                      <a:r>
-                        <a:rPr lang="en-US" sz="1100" u="none" strike="noStrike">
-                          <a:effectLst/>
-                        </a:rPr>
-                        <a:t>61.59</a:t>
-                      </a:r>
-                      <a:endParaRPr lang="en-US" sz="1100" b="0" i="0" u="none" strike="noStrike">
-                        <a:solidFill>
-                          <a:srgbClr val="000000"/>
-                        </a:solidFill>
-                        <a:effectLst/>
-                        <a:latin typeface="Calibri" panose="020F0502020204030204" pitchFamily="34" charset="0"/>
-                      </a:endParaRPr>
-                    </a:p>
-                  </a:txBody>
-                  <a:tcPr marL="7620" marR="7620" marT="7620" marB="0" anchor="b"/>
-                </a:tc>
-                <a:tc>
-                  <a:txBody>
-                    <a:bodyPr/>
-                    <a:lstStyle/>
-                    <a:p>
-                      <a:pPr algn="r" fontAlgn="b">
-                        <a:buNone/>
-                      </a:pPr>
-                      <a:r>
-                        <a:rPr lang="en-US" sz="1100" u="none" strike="noStrike">
-                          <a:effectLst/>
-                        </a:rPr>
-                        <a:t>0.9005</a:t>
-                      </a:r>
-                      <a:endParaRPr lang="en-US" sz="1100" b="0" i="0" u="none" strike="noStrike">
-                        <a:solidFill>
-                          <a:srgbClr val="000000"/>
-                        </a:solidFill>
-                        <a:effectLst/>
-                        <a:latin typeface="Calibri" panose="020F0502020204030204" pitchFamily="34" charset="0"/>
-                      </a:endParaRPr>
-                    </a:p>
-                  </a:txBody>
-                  <a:tcPr marL="7620" marR="7620" marT="7620" marB="0" anchor="b"/>
-                </a:tc>
-                <a:tc>
-                  <a:txBody>
-                    <a:bodyPr/>
-                    <a:lstStyle/>
-                    <a:p>
-                      <a:pPr algn="r" fontAlgn="b">
-                        <a:buNone/>
-                      </a:pPr>
-                      <a:r>
-                        <a:rPr lang="en-US" sz="1100" u="none" strike="noStrike">
-                          <a:effectLst/>
-                        </a:rPr>
-                        <a:t>0.8083</a:t>
-                      </a:r>
-                      <a:endParaRPr lang="en-US" sz="1100" b="0" i="0" u="none" strike="noStrike">
-                        <a:solidFill>
-                          <a:srgbClr val="000000"/>
-                        </a:solidFill>
-                        <a:effectLst/>
-                        <a:latin typeface="Calibri" panose="020F0502020204030204" pitchFamily="34" charset="0"/>
-                      </a:endParaRPr>
-                    </a:p>
-                  </a:txBody>
-                  <a:tcPr marL="7620" marR="7620" marT="7620" marB="0" anchor="b"/>
-                </a:tc>
-                <a:extLst>
-                  <a:ext uri="{0D108BD9-81ED-4DB2-BD59-A6C34878D82A}">
-                    <a16:rowId xmlns:a16="http://schemas.microsoft.com/office/drawing/2014/main" val="2835482938"/>
-                  </a:ext>
-                </a:extLst>
-              </a:tr>
-              <a:tr h="182880">
-                <a:tc>
-                  <a:txBody>
-                    <a:bodyPr/>
-                    <a:lstStyle/>
-                    <a:p>
-                      <a:pPr algn="l" fontAlgn="b">
-                        <a:buNone/>
-                      </a:pPr>
-                      <a:r>
-                        <a:rPr lang="en-US" sz="1100" u="none" strike="noStrike">
-                          <a:effectLst/>
-                        </a:rPr>
-                        <a:t>en→es</a:t>
-                      </a:r>
-                      <a:endParaRPr lang="en-US" sz="1100" b="0" i="0" u="none" strike="noStrike">
-                        <a:solidFill>
-                          <a:srgbClr val="000000"/>
-                        </a:solidFill>
-                        <a:effectLst/>
-                        <a:latin typeface="Calibri" panose="020F0502020204030204" pitchFamily="34" charset="0"/>
-                      </a:endParaRPr>
-                    </a:p>
-                  </a:txBody>
-                  <a:tcPr marL="7620" marR="7620" marT="7620" marB="0" anchor="b"/>
-                </a:tc>
-                <a:tc>
-                  <a:txBody>
-                    <a:bodyPr/>
-                    <a:lstStyle/>
-                    <a:p>
-                      <a:pPr algn="r" fontAlgn="b">
-                        <a:buNone/>
-                      </a:pPr>
-                      <a:r>
-                        <a:rPr lang="en-US" sz="1100" u="none" strike="noStrike">
-                          <a:effectLst/>
-                        </a:rPr>
-                        <a:t>61.86</a:t>
-                      </a:r>
-                      <a:endParaRPr lang="en-US" sz="1100" b="0" i="0" u="none" strike="noStrike">
-                        <a:solidFill>
-                          <a:srgbClr val="000000"/>
-                        </a:solidFill>
-                        <a:effectLst/>
-                        <a:latin typeface="Calibri" panose="020F0502020204030204" pitchFamily="34" charset="0"/>
-                      </a:endParaRPr>
-                    </a:p>
-                  </a:txBody>
-                  <a:tcPr marL="7620" marR="7620" marT="7620" marB="0" anchor="b"/>
-                </a:tc>
-                <a:tc>
-                  <a:txBody>
-                    <a:bodyPr/>
-                    <a:lstStyle/>
-                    <a:p>
-                      <a:pPr algn="r" fontAlgn="b">
-                        <a:buNone/>
-                      </a:pPr>
-                      <a:r>
-                        <a:rPr lang="en-US" sz="1100" u="none" strike="noStrike">
-                          <a:effectLst/>
-                        </a:rPr>
-                        <a:t>80.99</a:t>
-                      </a:r>
-                      <a:endParaRPr lang="en-US" sz="1100" b="0" i="0" u="none" strike="noStrike">
-                        <a:solidFill>
-                          <a:srgbClr val="000000"/>
-                        </a:solidFill>
-                        <a:effectLst/>
-                        <a:latin typeface="Calibri" panose="020F0502020204030204" pitchFamily="34" charset="0"/>
-                      </a:endParaRPr>
-                    </a:p>
-                  </a:txBody>
-                  <a:tcPr marL="7620" marR="7620" marT="7620" marB="0" anchor="b"/>
-                </a:tc>
-                <a:tc>
-                  <a:txBody>
-                    <a:bodyPr/>
-                    <a:lstStyle/>
-                    <a:p>
-                      <a:pPr algn="r" fontAlgn="b">
-                        <a:buNone/>
-                      </a:pPr>
-                      <a:r>
-                        <a:rPr lang="en-US" sz="1100" u="none" strike="noStrike">
-                          <a:effectLst/>
-                        </a:rPr>
-                        <a:t>87.86</a:t>
-                      </a:r>
-                      <a:endParaRPr lang="en-US" sz="1100" b="0" i="0" u="none" strike="noStrike">
-                        <a:solidFill>
-                          <a:srgbClr val="000000"/>
-                        </a:solidFill>
-                        <a:effectLst/>
-                        <a:latin typeface="Calibri" panose="020F0502020204030204" pitchFamily="34" charset="0"/>
-                      </a:endParaRPr>
-                    </a:p>
-                  </a:txBody>
-                  <a:tcPr marL="7620" marR="7620" marT="7620" marB="0" anchor="b"/>
-                </a:tc>
-                <a:tc>
-                  <a:txBody>
-                    <a:bodyPr/>
-                    <a:lstStyle/>
-                    <a:p>
-                      <a:pPr algn="r" fontAlgn="b">
-                        <a:buNone/>
-                      </a:pPr>
-                      <a:r>
-                        <a:rPr lang="en-US" sz="1100" u="none" strike="noStrike">
-                          <a:effectLst/>
-                        </a:rPr>
-                        <a:t>0.9112</a:t>
-                      </a:r>
-                      <a:endParaRPr lang="en-US" sz="1100" b="0" i="0" u="none" strike="noStrike">
-                        <a:solidFill>
-                          <a:srgbClr val="000000"/>
-                        </a:solidFill>
-                        <a:effectLst/>
-                        <a:latin typeface="Calibri" panose="020F0502020204030204" pitchFamily="34" charset="0"/>
-                      </a:endParaRPr>
-                    </a:p>
-                  </a:txBody>
-                  <a:tcPr marL="7620" marR="7620" marT="7620" marB="0" anchor="b"/>
-                </a:tc>
-                <a:tc>
-                  <a:txBody>
-                    <a:bodyPr/>
-                    <a:lstStyle/>
-                    <a:p>
-                      <a:pPr algn="r" fontAlgn="b">
-                        <a:buNone/>
-                      </a:pPr>
-                      <a:r>
-                        <a:rPr lang="en-US" sz="1100" u="none" strike="noStrike">
-                          <a:effectLst/>
-                        </a:rPr>
-                        <a:t>0.8129</a:t>
-                      </a:r>
-                      <a:endParaRPr lang="en-US" sz="1100" b="0" i="0" u="none" strike="noStrike">
-                        <a:solidFill>
-                          <a:srgbClr val="000000"/>
-                        </a:solidFill>
-                        <a:effectLst/>
-                        <a:latin typeface="Calibri" panose="020F0502020204030204" pitchFamily="34" charset="0"/>
-                      </a:endParaRPr>
-                    </a:p>
-                  </a:txBody>
-                  <a:tcPr marL="7620" marR="7620" marT="7620" marB="0" anchor="b"/>
-                </a:tc>
-                <a:tc>
-                  <a:txBody>
-                    <a:bodyPr/>
-                    <a:lstStyle/>
-                    <a:p>
-                      <a:pPr algn="r" fontAlgn="b">
-                        <a:buNone/>
-                      </a:pPr>
-                      <a:r>
-                        <a:rPr lang="en-US" sz="1100" u="none" strike="noStrike">
-                          <a:effectLst/>
-                        </a:rPr>
-                        <a:t>57.42</a:t>
-                      </a:r>
-                      <a:endParaRPr lang="en-US" sz="1100" b="0" i="0" u="none" strike="noStrike">
-                        <a:solidFill>
-                          <a:srgbClr val="000000"/>
-                        </a:solidFill>
-                        <a:effectLst/>
-                        <a:latin typeface="Calibri" panose="020F0502020204030204" pitchFamily="34" charset="0"/>
-                      </a:endParaRPr>
-                    </a:p>
-                  </a:txBody>
-                  <a:tcPr marL="7620" marR="7620" marT="7620" marB="0" anchor="b"/>
-                </a:tc>
-                <a:tc>
-                  <a:txBody>
-                    <a:bodyPr/>
-                    <a:lstStyle/>
-                    <a:p>
-                      <a:pPr algn="r" fontAlgn="b">
-                        <a:buNone/>
-                      </a:pPr>
-                      <a:r>
-                        <a:rPr lang="en-US" sz="1100" u="none" strike="noStrike">
-                          <a:effectLst/>
-                        </a:rPr>
-                        <a:t>77.91</a:t>
-                      </a:r>
-                      <a:endParaRPr lang="en-US" sz="1100" b="0" i="0" u="none" strike="noStrike">
-                        <a:solidFill>
-                          <a:srgbClr val="000000"/>
-                        </a:solidFill>
-                        <a:effectLst/>
-                        <a:latin typeface="Calibri" panose="020F0502020204030204" pitchFamily="34" charset="0"/>
-                      </a:endParaRPr>
-                    </a:p>
-                  </a:txBody>
-                  <a:tcPr marL="7620" marR="7620" marT="7620" marB="0" anchor="b"/>
-                </a:tc>
-                <a:tc>
-                  <a:txBody>
-                    <a:bodyPr/>
-                    <a:lstStyle/>
-                    <a:p>
-                      <a:pPr algn="r" fontAlgn="b">
-                        <a:buNone/>
-                      </a:pPr>
-                      <a:r>
-                        <a:rPr lang="en-US" sz="1100" u="none" strike="noStrike">
-                          <a:effectLst/>
-                        </a:rPr>
-                        <a:t>89.31</a:t>
-                      </a:r>
-                      <a:endParaRPr lang="en-US" sz="1100" b="0" i="0" u="none" strike="noStrike">
-                        <a:solidFill>
-                          <a:srgbClr val="000000"/>
-                        </a:solidFill>
-                        <a:effectLst/>
-                        <a:latin typeface="Calibri" panose="020F0502020204030204" pitchFamily="34" charset="0"/>
-                      </a:endParaRPr>
-                    </a:p>
-                  </a:txBody>
-                  <a:tcPr marL="7620" marR="7620" marT="7620" marB="0" anchor="b"/>
-                </a:tc>
-                <a:tc>
-                  <a:txBody>
-                    <a:bodyPr/>
-                    <a:lstStyle/>
-                    <a:p>
-                      <a:pPr algn="r" fontAlgn="b">
-                        <a:buNone/>
-                      </a:pPr>
-                      <a:r>
-                        <a:rPr lang="en-US" sz="1100" u="none" strike="noStrike">
-                          <a:effectLst/>
-                        </a:rPr>
-                        <a:t>0.9086</a:t>
-                      </a:r>
-                      <a:endParaRPr lang="en-US" sz="1100" b="0" i="0" u="none" strike="noStrike">
-                        <a:solidFill>
-                          <a:srgbClr val="000000"/>
-                        </a:solidFill>
-                        <a:effectLst/>
-                        <a:latin typeface="Calibri" panose="020F0502020204030204" pitchFamily="34" charset="0"/>
-                      </a:endParaRPr>
-                    </a:p>
-                  </a:txBody>
-                  <a:tcPr marL="7620" marR="7620" marT="7620" marB="0" anchor="b"/>
-                </a:tc>
-                <a:tc>
-                  <a:txBody>
-                    <a:bodyPr/>
-                    <a:lstStyle/>
-                    <a:p>
-                      <a:pPr algn="r" fontAlgn="b">
-                        <a:buNone/>
-                      </a:pPr>
-                      <a:r>
-                        <a:rPr lang="en-US" sz="1100" u="none" strike="noStrike">
-                          <a:effectLst/>
-                        </a:rPr>
-                        <a:t>0.807</a:t>
-                      </a:r>
-                      <a:endParaRPr lang="en-US" sz="1100" b="0" i="0" u="none" strike="noStrike">
-                        <a:solidFill>
-                          <a:srgbClr val="000000"/>
-                        </a:solidFill>
-                        <a:effectLst/>
-                        <a:latin typeface="Calibri" panose="020F0502020204030204" pitchFamily="34" charset="0"/>
-                      </a:endParaRPr>
-                    </a:p>
-                  </a:txBody>
-                  <a:tcPr marL="7620" marR="7620" marT="7620" marB="0" anchor="b"/>
-                </a:tc>
-                <a:extLst>
-                  <a:ext uri="{0D108BD9-81ED-4DB2-BD59-A6C34878D82A}">
-                    <a16:rowId xmlns:a16="http://schemas.microsoft.com/office/drawing/2014/main" val="2412859858"/>
-                  </a:ext>
-                </a:extLst>
-              </a:tr>
-              <a:tr h="182880">
-                <a:tc>
-                  <a:txBody>
-                    <a:bodyPr/>
-                    <a:lstStyle/>
-                    <a:p>
-                      <a:pPr algn="l" fontAlgn="b">
-                        <a:buNone/>
-                      </a:pPr>
-                      <a:r>
-                        <a:rPr lang="en-US" sz="1100" u="none" strike="noStrike">
-                          <a:effectLst/>
-                        </a:rPr>
-                        <a:t>en→ru</a:t>
-                      </a:r>
-                      <a:endParaRPr lang="en-US" sz="1100" b="0" i="0" u="none" strike="noStrike">
-                        <a:solidFill>
-                          <a:srgbClr val="000000"/>
-                        </a:solidFill>
-                        <a:effectLst/>
-                        <a:latin typeface="Calibri" panose="020F0502020204030204" pitchFamily="34" charset="0"/>
-                      </a:endParaRPr>
-                    </a:p>
-                  </a:txBody>
-                  <a:tcPr marL="7620" marR="7620" marT="7620" marB="0" anchor="b"/>
-                </a:tc>
-                <a:tc>
-                  <a:txBody>
-                    <a:bodyPr/>
-                    <a:lstStyle/>
-                    <a:p>
-                      <a:pPr algn="r" fontAlgn="b">
-                        <a:buNone/>
-                      </a:pPr>
-                      <a:r>
-                        <a:rPr lang="en-US" sz="1100" u="none" strike="noStrike">
-                          <a:effectLst/>
-                        </a:rPr>
-                        <a:t>45.45</a:t>
-                      </a:r>
-                      <a:endParaRPr lang="en-US" sz="1100" b="0" i="0" u="none" strike="noStrike">
-                        <a:solidFill>
-                          <a:srgbClr val="000000"/>
-                        </a:solidFill>
-                        <a:effectLst/>
-                        <a:latin typeface="Calibri" panose="020F0502020204030204" pitchFamily="34" charset="0"/>
-                      </a:endParaRPr>
-                    </a:p>
-                  </a:txBody>
-                  <a:tcPr marL="7620" marR="7620" marT="7620" marB="0" anchor="b"/>
-                </a:tc>
-                <a:tc>
-                  <a:txBody>
-                    <a:bodyPr/>
-                    <a:lstStyle/>
-                    <a:p>
-                      <a:pPr algn="r" fontAlgn="b">
-                        <a:buNone/>
-                      </a:pPr>
-                      <a:r>
-                        <a:rPr lang="en-US" sz="1100" u="none" strike="noStrike">
-                          <a:effectLst/>
-                        </a:rPr>
-                        <a:t>71.89</a:t>
-                      </a:r>
-                      <a:endParaRPr lang="en-US" sz="1100" b="0" i="0" u="none" strike="noStrike">
-                        <a:solidFill>
-                          <a:srgbClr val="000000"/>
-                        </a:solidFill>
-                        <a:effectLst/>
-                        <a:latin typeface="Calibri" panose="020F0502020204030204" pitchFamily="34" charset="0"/>
-                      </a:endParaRPr>
-                    </a:p>
-                  </a:txBody>
-                  <a:tcPr marL="7620" marR="7620" marT="7620" marB="0" anchor="b"/>
-                </a:tc>
-                <a:tc>
-                  <a:txBody>
-                    <a:bodyPr/>
-                    <a:lstStyle/>
-                    <a:p>
-                      <a:pPr algn="r" fontAlgn="b">
-                        <a:buNone/>
-                      </a:pPr>
-                      <a:r>
-                        <a:rPr lang="en-US" sz="1100" u="none" strike="noStrike">
-                          <a:effectLst/>
-                        </a:rPr>
-                        <a:t>68.92</a:t>
-                      </a:r>
-                      <a:endParaRPr lang="en-US" sz="1100" b="0" i="0" u="none" strike="noStrike">
-                        <a:solidFill>
-                          <a:srgbClr val="000000"/>
-                        </a:solidFill>
-                        <a:effectLst/>
-                        <a:latin typeface="Calibri" panose="020F0502020204030204" pitchFamily="34" charset="0"/>
-                      </a:endParaRPr>
-                    </a:p>
-                  </a:txBody>
-                  <a:tcPr marL="7620" marR="7620" marT="7620" marB="0" anchor="b"/>
-                </a:tc>
-                <a:tc>
-                  <a:txBody>
-                    <a:bodyPr/>
-                    <a:lstStyle/>
-                    <a:p>
-                      <a:pPr algn="r" fontAlgn="b">
-                        <a:buNone/>
-                      </a:pPr>
-                      <a:r>
-                        <a:rPr lang="en-US" sz="1100" u="none" strike="noStrike">
-                          <a:effectLst/>
-                        </a:rPr>
-                        <a:t>0.8886</a:t>
-                      </a:r>
-                      <a:endParaRPr lang="en-US" sz="1100" b="0" i="0" u="none" strike="noStrike">
-                        <a:solidFill>
-                          <a:srgbClr val="000000"/>
-                        </a:solidFill>
-                        <a:effectLst/>
-                        <a:latin typeface="Calibri" panose="020F0502020204030204" pitchFamily="34" charset="0"/>
-                      </a:endParaRPr>
-                    </a:p>
-                  </a:txBody>
-                  <a:tcPr marL="7620" marR="7620" marT="7620" marB="0" anchor="b"/>
-                </a:tc>
-                <a:tc>
-                  <a:txBody>
-                    <a:bodyPr/>
-                    <a:lstStyle/>
-                    <a:p>
-                      <a:pPr algn="r" fontAlgn="b">
-                        <a:buNone/>
-                      </a:pPr>
-                      <a:r>
-                        <a:rPr lang="en-US" sz="1100" u="none" strike="noStrike">
-                          <a:effectLst/>
-                        </a:rPr>
-                        <a:t>0.7101</a:t>
-                      </a:r>
-                      <a:endParaRPr lang="en-US" sz="1100" b="0" i="0" u="none" strike="noStrike">
-                        <a:solidFill>
-                          <a:srgbClr val="000000"/>
-                        </a:solidFill>
-                        <a:effectLst/>
-                        <a:latin typeface="Calibri" panose="020F0502020204030204" pitchFamily="34" charset="0"/>
-                      </a:endParaRPr>
-                    </a:p>
-                  </a:txBody>
-                  <a:tcPr marL="7620" marR="7620" marT="7620" marB="0" anchor="b"/>
-                </a:tc>
-                <a:tc>
-                  <a:txBody>
-                    <a:bodyPr/>
-                    <a:lstStyle/>
-                    <a:p>
-                      <a:pPr algn="r" fontAlgn="b">
-                        <a:buNone/>
-                      </a:pPr>
-                      <a:r>
-                        <a:rPr lang="en-US" sz="1100" u="none" strike="noStrike">
-                          <a:effectLst/>
-                        </a:rPr>
-                        <a:t>37.19</a:t>
-                      </a:r>
-                      <a:endParaRPr lang="en-US" sz="1100" b="0" i="0" u="none" strike="noStrike">
-                        <a:solidFill>
-                          <a:srgbClr val="000000"/>
-                        </a:solidFill>
-                        <a:effectLst/>
-                        <a:latin typeface="Calibri" panose="020F0502020204030204" pitchFamily="34" charset="0"/>
-                      </a:endParaRPr>
-                    </a:p>
-                  </a:txBody>
-                  <a:tcPr marL="7620" marR="7620" marT="7620" marB="0" anchor="b"/>
-                </a:tc>
-                <a:tc>
-                  <a:txBody>
-                    <a:bodyPr/>
-                    <a:lstStyle/>
-                    <a:p>
-                      <a:pPr algn="r" fontAlgn="b">
-                        <a:buNone/>
-                      </a:pPr>
-                      <a:r>
-                        <a:rPr lang="en-US" sz="1100" u="none" strike="noStrike">
-                          <a:effectLst/>
-                        </a:rPr>
-                        <a:t>68.09</a:t>
-                      </a:r>
-                      <a:endParaRPr lang="en-US" sz="1100" b="0" i="0" u="none" strike="noStrike">
-                        <a:solidFill>
-                          <a:srgbClr val="000000"/>
-                        </a:solidFill>
-                        <a:effectLst/>
-                        <a:latin typeface="Calibri" panose="020F0502020204030204" pitchFamily="34" charset="0"/>
-                      </a:endParaRPr>
-                    </a:p>
-                  </a:txBody>
-                  <a:tcPr marL="7620" marR="7620" marT="7620" marB="0" anchor="b"/>
-                </a:tc>
-                <a:tc>
-                  <a:txBody>
-                    <a:bodyPr/>
-                    <a:lstStyle/>
-                    <a:p>
-                      <a:pPr algn="r" fontAlgn="b">
-                        <a:buNone/>
-                      </a:pPr>
-                      <a:r>
-                        <a:rPr lang="en-US" sz="1100" u="none" strike="noStrike">
-                          <a:effectLst/>
-                        </a:rPr>
-                        <a:t>73.51</a:t>
-                      </a:r>
-                      <a:endParaRPr lang="en-US" sz="1100" b="0" i="0" u="none" strike="noStrike">
-                        <a:solidFill>
-                          <a:srgbClr val="000000"/>
-                        </a:solidFill>
-                        <a:effectLst/>
-                        <a:latin typeface="Calibri" panose="020F0502020204030204" pitchFamily="34" charset="0"/>
-                      </a:endParaRPr>
-                    </a:p>
-                  </a:txBody>
-                  <a:tcPr marL="7620" marR="7620" marT="7620" marB="0" anchor="b"/>
-                </a:tc>
-                <a:tc>
-                  <a:txBody>
-                    <a:bodyPr/>
-                    <a:lstStyle/>
-                    <a:p>
-                      <a:pPr algn="r" fontAlgn="b">
-                        <a:buNone/>
-                      </a:pPr>
-                      <a:r>
-                        <a:rPr lang="en-US" sz="1100" u="none" strike="noStrike">
-                          <a:effectLst/>
-                        </a:rPr>
-                        <a:t>0.8916</a:t>
-                      </a:r>
-                      <a:endParaRPr lang="en-US" sz="1100" b="0" i="0" u="none" strike="noStrike">
-                        <a:solidFill>
-                          <a:srgbClr val="000000"/>
-                        </a:solidFill>
-                        <a:effectLst/>
-                        <a:latin typeface="Calibri" panose="020F0502020204030204" pitchFamily="34" charset="0"/>
-                      </a:endParaRPr>
-                    </a:p>
-                  </a:txBody>
-                  <a:tcPr marL="7620" marR="7620" marT="7620" marB="0" anchor="b"/>
-                </a:tc>
-                <a:tc>
-                  <a:txBody>
-                    <a:bodyPr/>
-                    <a:lstStyle/>
-                    <a:p>
-                      <a:pPr algn="r" fontAlgn="b">
-                        <a:buNone/>
-                      </a:pPr>
-                      <a:r>
-                        <a:rPr lang="en-US" sz="1100" u="none" strike="noStrike">
-                          <a:effectLst/>
-                        </a:rPr>
-                        <a:t>0.7043</a:t>
-                      </a:r>
-                      <a:endParaRPr lang="en-US" sz="1100" b="0" i="0" u="none" strike="noStrike">
-                        <a:solidFill>
-                          <a:srgbClr val="000000"/>
-                        </a:solidFill>
-                        <a:effectLst/>
-                        <a:latin typeface="Calibri" panose="020F0502020204030204" pitchFamily="34" charset="0"/>
-                      </a:endParaRPr>
-                    </a:p>
-                  </a:txBody>
-                  <a:tcPr marL="7620" marR="7620" marT="7620" marB="0" anchor="b"/>
-                </a:tc>
-                <a:extLst>
-                  <a:ext uri="{0D108BD9-81ED-4DB2-BD59-A6C34878D82A}">
-                    <a16:rowId xmlns:a16="http://schemas.microsoft.com/office/drawing/2014/main" val="3584537214"/>
-                  </a:ext>
-                </a:extLst>
-              </a:tr>
-              <a:tr h="182880">
-                <a:tc>
-                  <a:txBody>
-                    <a:bodyPr/>
-                    <a:lstStyle/>
-                    <a:p>
-                      <a:pPr algn="l" fontAlgn="b">
-                        <a:buNone/>
-                      </a:pPr>
-                      <a:r>
-                        <a:rPr lang="en-US" sz="1100" u="none" strike="noStrike">
-                          <a:effectLst/>
-                        </a:rPr>
-                        <a:t>MACRO_AVG</a:t>
-                      </a:r>
-                      <a:endParaRPr lang="en-US" sz="1100" b="0" i="0" u="none" strike="noStrike">
-                        <a:solidFill>
-                          <a:srgbClr val="000000"/>
-                        </a:solidFill>
-                        <a:effectLst/>
-                        <a:latin typeface="Calibri" panose="020F0502020204030204" pitchFamily="34" charset="0"/>
-                      </a:endParaRPr>
-                    </a:p>
-                  </a:txBody>
-                  <a:tcPr marL="7620" marR="7620" marT="7620" marB="0" anchor="b"/>
-                </a:tc>
-                <a:tc>
-                  <a:txBody>
-                    <a:bodyPr/>
-                    <a:lstStyle/>
-                    <a:p>
-                      <a:pPr algn="r" fontAlgn="b">
-                        <a:buNone/>
-                      </a:pPr>
-                      <a:r>
-                        <a:rPr lang="en-US" sz="1100" u="none" strike="noStrike">
-                          <a:effectLst/>
-                        </a:rPr>
-                        <a:t>51.2</a:t>
-                      </a:r>
-                      <a:endParaRPr lang="en-US" sz="1100" b="0" i="0" u="none" strike="noStrike">
-                        <a:solidFill>
-                          <a:srgbClr val="000000"/>
-                        </a:solidFill>
-                        <a:effectLst/>
-                        <a:latin typeface="Calibri" panose="020F0502020204030204" pitchFamily="34" charset="0"/>
-                      </a:endParaRPr>
-                    </a:p>
-                  </a:txBody>
-                  <a:tcPr marL="7620" marR="7620" marT="7620" marB="0" anchor="b"/>
-                </a:tc>
-                <a:tc>
-                  <a:txBody>
-                    <a:bodyPr/>
-                    <a:lstStyle/>
-                    <a:p>
-                      <a:pPr algn="r" fontAlgn="b">
-                        <a:buNone/>
-                      </a:pPr>
-                      <a:r>
-                        <a:rPr lang="en-US" sz="1100" u="none" strike="noStrike">
-                          <a:effectLst/>
-                        </a:rPr>
-                        <a:t>74.98</a:t>
-                      </a:r>
-                      <a:endParaRPr lang="en-US" sz="1100" b="0" i="0" u="none" strike="noStrike">
-                        <a:solidFill>
-                          <a:srgbClr val="000000"/>
-                        </a:solidFill>
-                        <a:effectLst/>
-                        <a:latin typeface="Calibri" panose="020F0502020204030204" pitchFamily="34" charset="0"/>
-                      </a:endParaRPr>
-                    </a:p>
-                  </a:txBody>
-                  <a:tcPr marL="7620" marR="7620" marT="7620" marB="0" anchor="b"/>
-                </a:tc>
-                <a:tc>
-                  <a:txBody>
-                    <a:bodyPr/>
-                    <a:lstStyle/>
-                    <a:p>
-                      <a:pPr algn="r" fontAlgn="b">
-                        <a:buNone/>
-                      </a:pPr>
-                      <a:r>
-                        <a:rPr lang="en-US" sz="1100" u="none" strike="noStrike">
-                          <a:effectLst/>
-                        </a:rPr>
-                        <a:t>70.79</a:t>
-                      </a:r>
-                      <a:endParaRPr lang="en-US" sz="1100" b="0" i="0" u="none" strike="noStrike">
-                        <a:solidFill>
-                          <a:srgbClr val="000000"/>
-                        </a:solidFill>
-                        <a:effectLst/>
-                        <a:latin typeface="Calibri" panose="020F0502020204030204" pitchFamily="34" charset="0"/>
-                      </a:endParaRPr>
-                    </a:p>
-                  </a:txBody>
-                  <a:tcPr marL="7620" marR="7620" marT="7620" marB="0" anchor="b"/>
-                </a:tc>
-                <a:tc>
-                  <a:txBody>
-                    <a:bodyPr/>
-                    <a:lstStyle/>
-                    <a:p>
-                      <a:pPr algn="r" fontAlgn="b">
-                        <a:buNone/>
-                      </a:pPr>
-                      <a:r>
-                        <a:rPr lang="en-US" sz="1100" u="none" strike="noStrike">
-                          <a:effectLst/>
-                        </a:rPr>
-                        <a:t>0.8992</a:t>
-                      </a:r>
-                      <a:endParaRPr lang="en-US" sz="1100" b="0" i="0" u="none" strike="noStrike">
-                        <a:solidFill>
-                          <a:srgbClr val="000000"/>
-                        </a:solidFill>
-                        <a:effectLst/>
-                        <a:latin typeface="Calibri" panose="020F0502020204030204" pitchFamily="34" charset="0"/>
-                      </a:endParaRPr>
-                    </a:p>
-                  </a:txBody>
-                  <a:tcPr marL="7620" marR="7620" marT="7620" marB="0" anchor="b"/>
-                </a:tc>
-                <a:tc>
-                  <a:txBody>
-                    <a:bodyPr/>
-                    <a:lstStyle/>
-                    <a:p>
-                      <a:pPr algn="r" fontAlgn="b">
-                        <a:buNone/>
-                      </a:pPr>
-                      <a:r>
-                        <a:rPr lang="en-US" sz="1100" u="none" strike="noStrike">
-                          <a:effectLst/>
-                        </a:rPr>
-                        <a:t>0.7741</a:t>
-                      </a:r>
-                      <a:endParaRPr lang="en-US" sz="1100" b="0" i="0" u="none" strike="noStrike">
-                        <a:solidFill>
-                          <a:srgbClr val="000000"/>
-                        </a:solidFill>
-                        <a:effectLst/>
-                        <a:latin typeface="Calibri" panose="020F0502020204030204" pitchFamily="34" charset="0"/>
-                      </a:endParaRPr>
-                    </a:p>
-                  </a:txBody>
-                  <a:tcPr marL="7620" marR="7620" marT="7620" marB="0" anchor="b"/>
-                </a:tc>
-                <a:tc>
-                  <a:txBody>
-                    <a:bodyPr/>
-                    <a:lstStyle/>
-                    <a:p>
-                      <a:pPr algn="r" fontAlgn="b">
-                        <a:buNone/>
-                      </a:pPr>
-                      <a:r>
-                        <a:rPr lang="en-US" sz="1100" u="none" strike="noStrike">
-                          <a:effectLst/>
-                        </a:rPr>
-                        <a:t>47.48</a:t>
-                      </a:r>
-                      <a:endParaRPr lang="en-US" sz="1100" b="0" i="0" u="none" strike="noStrike">
-                        <a:solidFill>
-                          <a:srgbClr val="000000"/>
-                        </a:solidFill>
-                        <a:effectLst/>
-                        <a:latin typeface="Calibri" panose="020F0502020204030204" pitchFamily="34" charset="0"/>
-                      </a:endParaRPr>
-                    </a:p>
-                  </a:txBody>
-                  <a:tcPr marL="7620" marR="7620" marT="7620" marB="0" anchor="b"/>
-                </a:tc>
-                <a:tc>
-                  <a:txBody>
-                    <a:bodyPr/>
-                    <a:lstStyle/>
-                    <a:p>
-                      <a:pPr algn="r" fontAlgn="b">
-                        <a:buNone/>
-                      </a:pPr>
-                      <a:r>
-                        <a:rPr lang="en-US" sz="1100" u="none" strike="noStrike">
-                          <a:effectLst/>
-                        </a:rPr>
-                        <a:t>73.25</a:t>
-                      </a:r>
-                      <a:endParaRPr lang="en-US" sz="1100" b="0" i="0" u="none" strike="noStrike">
-                        <a:solidFill>
-                          <a:srgbClr val="000000"/>
-                        </a:solidFill>
-                        <a:effectLst/>
-                        <a:latin typeface="Calibri" panose="020F0502020204030204" pitchFamily="34" charset="0"/>
-                      </a:endParaRPr>
-                    </a:p>
-                  </a:txBody>
-                  <a:tcPr marL="7620" marR="7620" marT="7620" marB="0" anchor="b"/>
-                </a:tc>
-                <a:tc>
-                  <a:txBody>
-                    <a:bodyPr/>
-                    <a:lstStyle/>
-                    <a:p>
-                      <a:pPr algn="r" fontAlgn="b">
-                        <a:buNone/>
-                      </a:pPr>
-                      <a:r>
-                        <a:rPr lang="en-US" sz="1100" u="none" strike="noStrike">
-                          <a:effectLst/>
-                        </a:rPr>
-                        <a:t>74.8</a:t>
-                      </a:r>
-                      <a:endParaRPr lang="en-US" sz="1100" b="0" i="0" u="none" strike="noStrike">
-                        <a:solidFill>
-                          <a:srgbClr val="000000"/>
-                        </a:solidFill>
-                        <a:effectLst/>
-                        <a:latin typeface="Calibri" panose="020F0502020204030204" pitchFamily="34" charset="0"/>
-                      </a:endParaRPr>
-                    </a:p>
-                  </a:txBody>
-                  <a:tcPr marL="7620" marR="7620" marT="7620" marB="0" anchor="b"/>
-                </a:tc>
-                <a:tc>
-                  <a:txBody>
-                    <a:bodyPr/>
-                    <a:lstStyle/>
-                    <a:p>
-                      <a:pPr algn="r" fontAlgn="b">
-                        <a:buNone/>
-                      </a:pPr>
-                      <a:r>
-                        <a:rPr lang="en-US" sz="1100" u="none" strike="noStrike">
-                          <a:effectLst/>
-                        </a:rPr>
-                        <a:t>0.9002</a:t>
-                      </a:r>
-                      <a:endParaRPr lang="en-US" sz="1100" b="0" i="0" u="none" strike="noStrike">
-                        <a:solidFill>
-                          <a:srgbClr val="000000"/>
-                        </a:solidFill>
-                        <a:effectLst/>
-                        <a:latin typeface="Calibri" panose="020F0502020204030204" pitchFamily="34" charset="0"/>
-                      </a:endParaRPr>
-                    </a:p>
-                  </a:txBody>
-                  <a:tcPr marL="7620" marR="7620" marT="7620" marB="0" anchor="b"/>
-                </a:tc>
-                <a:tc>
-                  <a:txBody>
-                    <a:bodyPr/>
-                    <a:lstStyle/>
-                    <a:p>
-                      <a:pPr algn="r" fontAlgn="b">
-                        <a:buNone/>
-                      </a:pPr>
-                      <a:r>
-                        <a:rPr lang="en-US" sz="1100" u="none" strike="noStrike" dirty="0">
-                          <a:effectLst/>
-                        </a:rPr>
-                        <a:t>0.7732</a:t>
-                      </a:r>
-                      <a:endParaRPr lang="en-US" sz="1100" b="0" i="0" u="none" strike="noStrike" dirty="0">
-                        <a:solidFill>
-                          <a:srgbClr val="000000"/>
-                        </a:solidFill>
-                        <a:effectLst/>
-                        <a:latin typeface="Calibri" panose="020F0502020204030204" pitchFamily="34" charset="0"/>
-                      </a:endParaRPr>
-                    </a:p>
-                  </a:txBody>
-                  <a:tcPr marL="7620" marR="7620" marT="7620" marB="0" anchor="b"/>
-                </a:tc>
-                <a:extLst>
-                  <a:ext uri="{0D108BD9-81ED-4DB2-BD59-A6C34878D82A}">
-                    <a16:rowId xmlns:a16="http://schemas.microsoft.com/office/drawing/2014/main" val="1394302760"/>
-                  </a:ext>
-                </a:extLst>
-              </a:tr>
-            </a:tbl>
-          </a:graphicData>
-        </a:graphic>
-      </p:graphicFrame>
-      <p:pic>
-        <p:nvPicPr>
-          <p:cNvPr id="28" name="Picture 27">
-            <a:extLst>
-              <a:ext uri="{FF2B5EF4-FFF2-40B4-BE49-F238E27FC236}">
-                <a16:creationId xmlns:a16="http://schemas.microsoft.com/office/drawing/2014/main" id="{5E3FCE4D-E042-89E2-9DF0-21EE57A3776C}"/>
-              </a:ext>
-            </a:extLst>
-          </p:cNvPr>
-          <p:cNvPicPr>
-            <a:picLocks noChangeAspect="1"/>
-          </p:cNvPicPr>
-          <p:nvPr/>
-        </p:nvPicPr>
-        <p:blipFill>
-          <a:blip r:embed="rId6"/>
-          <a:stretch>
-            <a:fillRect/>
-          </a:stretch>
-        </p:blipFill>
-        <p:spPr>
-          <a:xfrm>
-            <a:off x="2194493" y="25023672"/>
-            <a:ext cx="20788697" cy="2543765"/>
-          </a:xfrm>
-          <a:prstGeom prst="rect">
-            <a:avLst/>
-          </a:prstGeom>
-        </p:spPr>
-      </p:pic>
     </p:spTree>
     <p:extLst>
       <p:ext uri="{BB962C8B-B14F-4D97-AF65-F5344CB8AC3E}">

</xml_diff>